<commit_message>
Update author names to 吳昀慶、張芸翠、朱穎芃 in slides and PPTX
Co-Authored-By: Claude <noreply@anthropic.com>
</commit_message>
<xml_diff>
--- a/舊地圖散策_專案簡報.pptx
+++ b/舊地圖散策_專案簡報.pptx
@@ -3395,7 +3395,7 @@
                 <a:latin typeface="JetBrains Mono"/>
                 <a:ea typeface="JetBrains Mono"/>
               </a:rPr>
-              <a:t>吳昀慶　Yunching Wu</a:t>
+              <a:t>吳昀慶、張芸翠、朱穎芃</a:t>
             </a:r>
           </a:p>
         </p:txBody>
@@ -3770,7 +3770,7 @@
                 <a:latin typeface="JetBrains Mono"/>
                 <a:ea typeface="JetBrains Mono"/>
               </a:rPr>
-              <a:t>吳昀慶　Yunching Wu　·　github.com/yunching0513</a:t>
+              <a:t>吳昀慶、張芸翠、朱穎芃</a:t>
             </a:r>
           </a:p>
         </p:txBody>

</xml_diff>